<commit_message>
docs: regenera apresentacoes (3 decks) com numeros atualizados pos educ_missing
Re-run das apresentacoes tecnica e executivas com os parametros corrigidos
(educ_missing): OR_negro 0,676/0,693, OB 84%/16%, random slopes glmer atualizados.
Sem alteracao de codigo dos geradores; apenas regeneracao dos artefatos.

Co-Authored-By: Claude Opus 4.8 <noreply@anthropic.com>
</commit_message>
<xml_diff>
--- a/apresentacao_executiva_tcc.pptx
+++ b/apresentacao_executiva_tcc.pptx
@@ -4334,7 +4334,7 @@
                 </a:solidFill>
                 <a:latin typeface="Calibri"/>
               </a:rPr>
-              <a:t>0,691</a:t>
+              <a:t>0,693</a:t>
             </a:r>
           </a:p>
         </p:txBody>
@@ -5022,7 +5022,7 @@
                 </a:solidFill>
                 <a:latin typeface="Calibri"/>
               </a:rPr>
-              <a:t>O gap varia de -19.8% a -2.2% entre estados (random slope HLM, N=7.689.426). Estados mais ricos (DF, RJ, SP) concentram a MAIOR penalidade.</a:t>
+              <a:t>O gap varia de -19.7% a -2.1% entre estados (random slope HLM, N=7.689.426). Estados mais ricos (DF, RJ, SP) concentram a MAIOR penalidade.</a:t>
             </a:r>
           </a:p>
         </p:txBody>
@@ -6431,7 +6431,7 @@
                 </a:solidFill>
                 <a:latin typeface="Calibri"/>
               </a:rPr>
-              <a:t>▸  Negros tem 30,9% menos chance de obter
+              <a:t>▸  Negros tem 30,7% menos chance de obter
 ocupacao qualificada (GLMM M2)</a:t>
             </a:r>
           </a:p>
@@ -8587,7 +8587,7 @@
                 </a:solidFill>
                 <a:latin typeface="Calibri"/>
               </a:rPr>
-              <a:t>0,691</a:t>
+              <a:t>0,693</a:t>
             </a:r>
           </a:p>
         </p:txBody>
@@ -8737,7 +8737,7 @@
                 </a:solidFill>
                 <a:latin typeface="Calibri"/>
               </a:rPr>
-              <a:t>−4,84 p.p.</a:t>
+              <a:t>−4,75 p.p.</a:t>
             </a:r>
           </a:p>
         </p:txBody>
@@ -8854,7 +8854,7 @@
               </a:rPr>
               <a:t>Mesmo com EDUCACAO, SEXO, IDADE e BAIRRO
 IDENTICOS aos de um branco, um trabalhador
-negro tem 30,9% MENOS chance de trabalho qualificado.</a:t>
+negro tem 30,7% MENOS chance de trabalho qualificado.</a:t>
             </a:r>
           </a:p>
         </p:txBody>
@@ -10212,7 +10212,7 @@
                 </a:solidFill>
                 <a:latin typeface="Calibri"/>
               </a:rPr>
-              <a:t>Genero (GLMM random slope): o teto de vidro feminino e de RENDA, nao de categoria — mulheres acessam ocupacoes qualificadas (OR=2,01) mas nao o topo de renda (OR top10=0,522).</a:t>
+              <a:t>Genero (GLMM random slope): o teto de vidro feminino e de RENDA, nao de categoria — mulheres acessam ocupacoes qualificadas (OR=1,99) mas nao o topo de renda (OR top10=0,518).</a:t>
             </a:r>
           </a:p>
         </p:txBody>
@@ -10733,7 +10733,7 @@
                 </a:solidFill>
                 <a:latin typeface="Calibri"/>
               </a:rPr>
-              <a:t>Amplitude -20% a -2% entre UFs | LRT LR=7612, p&lt;0,001*** — maior penalidade nos estados mais ricos (DF, RJ, SP), nao nos mais pobres.</a:t>
+              <a:t>Amplitude -20% a -2% entre UFs | LRT LR=7548, p&lt;0,001*** — maior penalidade nos estados mais ricos (DF, RJ, SP), nao nos mais pobres.</a:t>
             </a:r>
           </a:p>
         </p:txBody>
@@ -11431,7 +11431,7 @@
                 </a:solidFill>
                 <a:latin typeface="Calibri"/>
               </a:rPr>
-              <a:t>E &gt;= 2,25x</a:t>
+              <a:t>E &gt;= 2,24x</a:t>
             </a:r>
           </a:p>
         </p:txBody>

</xml_diff>

<commit_message>
feat: decks executivos (interseccionalidade + nota IBGE) e triangulacao IPS
- 2 decks executivos: slide de interseccionalidade (grupo_rg flip — mulher negra
  alcada no acesso, a mais excluida no topo) + nota de contexto IBGE; lay deck
  renumerado (14 slides).
- Paragrafo de triangulacao com o IPS (Imazon 2026) no relatorio (.tex/Word):
  corroboracao externa do eixo territorial, com ressalva de que merge fino e
  inviavel (PNAD nao tem municipio; IPS e municipal, mais grosso que a UPA).
- Guia: literais das ORs interseccionais nas citacoes agora sourced de params
  (evita drift); validador com skip GRG_MB_TOP10 (colide com Gini IBGE ~0,49).
Validador verde; PDF 32 pp.

Co-Authored-By: Claude Opus 4.8 <noreply@anthropic.com>
</commit_message>
<xml_diff>
--- a/apresentacao_executiva_tcc.pptx
+++ b/apresentacao_executiva_tcc.pptx
@@ -15,6 +15,7 @@
     <p:sldId id="263" r:id="rId14"/>
     <p:sldId id="264" r:id="rId15"/>
     <p:sldId id="265" r:id="rId16"/>
+    <p:sldId id="266" r:id="rId17"/>
   </p:sldIdLst>
   <p:sldSz cx="12188952" cy="6858000" type="screen4x3"/>
   <p:notesSz cx="6858000" cy="9144000"/>
@@ -3851,7 +3852,7 @@
         <p:spPr>
           <a:xfrm>
             <a:off x="0" y="0"/>
-            <a:ext cx="12188952" cy="6858000"/>
+            <a:ext cx="12188952" cy="960120"/>
           </a:xfrm>
           <a:prstGeom prst="rect">
             <a:avLst/>
@@ -3885,14 +3886,108 @@
       </p:sp>
       <p:sp>
         <p:nvSpPr>
-          <p:cNvPr id="3" name="Rectangle 2"/>
+          <p:cNvPr id="3" name="TextBox 2"/>
+          <p:cNvSpPr txBox="1"/>
+          <p:nvPr/>
+        </p:nvSpPr>
+        <p:spPr>
+          <a:xfrm>
+            <a:off x="320040" y="64008"/>
+            <a:ext cx="11430000" cy="502920"/>
+          </a:xfrm>
+          <a:prstGeom prst="rect">
+            <a:avLst/>
+          </a:prstGeom>
+          <a:noFill/>
+        </p:spPr>
+        <p:txBody>
+          <a:bodyPr wrap="square">
+            <a:spAutoFit/>
+          </a:bodyPr>
+          <a:lstStyle/>
+          <a:p>
+            <a:pPr algn="l"/>
+            <a:r>
+              <a:rPr sz="2700" b="1" i="0">
+                <a:solidFill>
+                  <a:srgbClr val="FFFFFF"/>
+                </a:solidFill>
+                <a:latin typeface="Calibri"/>
+              </a:rPr>
+              <a:t>9. Interseccionalidade — O Teto de Vidro Recai sobre a Mulher Negra</a:t>
+            </a:r>
+          </a:p>
+        </p:txBody>
+      </p:sp>
+      <p:sp>
+        <p:nvSpPr>
+          <p:cNvPr id="4" name="TextBox 3"/>
+          <p:cNvSpPr txBox="1"/>
+          <p:nvPr/>
+        </p:nvSpPr>
+        <p:spPr>
+          <a:xfrm>
+            <a:off x="320040" y="576072"/>
+            <a:ext cx="11430000" cy="320040"/>
+          </a:xfrm>
+          <a:prstGeom prst="rect">
+            <a:avLst/>
+          </a:prstGeom>
+          <a:noFill/>
+        </p:spPr>
+        <p:txBody>
+          <a:bodyPr wrap="square">
+            <a:spAutoFit/>
+          </a:bodyPr>
+          <a:lstStyle/>
+          <a:p>
+            <a:pPr algn="l"/>
+            <a:r>
+              <a:rPr sz="1350" b="0" i="0">
+                <a:solidFill>
+                  <a:srgbClr val="BBDEFB"/>
+                </a:solidFill>
+                <a:latin typeface="Calibri"/>
+              </a:rPr>
+              <a:t>4 grupos raca x genero (ref. homem branco): alcada no acesso, a mais excluida no topo da renda</a:t>
+            </a:r>
+          </a:p>
+        </p:txBody>
+      </p:sp>
+      <p:pic>
+        <p:nvPicPr>
+          <p:cNvPr id="5" name="Picture 4" descr="grupo_rg_interseccional.png"/>
+          <p:cNvPicPr>
+            <a:picLocks noChangeAspect="1"/>
+          </p:cNvPicPr>
+          <p:nvPr/>
+        </p:nvPicPr>
+        <p:blipFill>
+          <a:blip r:embed="rId2"/>
+          <a:stretch>
+            <a:fillRect/>
+          </a:stretch>
+        </p:blipFill>
+        <p:spPr>
+          <a:xfrm>
+            <a:off x="365760" y="1188720"/>
+            <a:ext cx="6949440" cy="4595360"/>
+          </a:xfrm>
+          <a:prstGeom prst="rect">
+            <a:avLst/>
+          </a:prstGeom>
+        </p:spPr>
+      </p:pic>
+      <p:sp>
+        <p:nvSpPr>
+          <p:cNvPr id="6" name="Rectangle 5"/>
           <p:cNvSpPr/>
           <p:nvPr/>
         </p:nvSpPr>
         <p:spPr>
           <a:xfrm>
-            <a:off x="0" y="0"/>
-            <a:ext cx="12188952" cy="685800"/>
+            <a:off x="7589520" y="1371600"/>
+            <a:ext cx="4206240" cy="1645920"/>
           </a:xfrm>
           <a:prstGeom prst="rect">
             <a:avLst/>
@@ -3900,7 +3995,11 @@
           <a:solidFill>
             <a:srgbClr val="0D1F3C"/>
           </a:solidFill>
-          <a:ln/>
+          <a:ln w="19050">
+            <a:solidFill>
+              <a:srgbClr val="FF8F00"/>
+            </a:solidFill>
+          </a:ln>
         </p:spPr>
         <p:style>
           <a:lnRef idx="1">
@@ -3926,6 +4025,552 @@
       </p:sp>
       <p:sp>
         <p:nvSpPr>
+          <p:cNvPr id="7" name="TextBox 6"/>
+          <p:cNvSpPr txBox="1"/>
+          <p:nvPr/>
+        </p:nvSpPr>
+        <p:spPr>
+          <a:xfrm>
+            <a:off x="7699248" y="1444752"/>
+            <a:ext cx="3986784" cy="347472"/>
+          </a:xfrm>
+          <a:prstGeom prst="rect">
+            <a:avLst/>
+          </a:prstGeom>
+          <a:noFill/>
+        </p:spPr>
+        <p:txBody>
+          <a:bodyPr wrap="square">
+            <a:spAutoFit/>
+          </a:bodyPr>
+          <a:lstStyle/>
+          <a:p>
+            <a:pPr algn="l"/>
+            <a:r>
+              <a:rPr sz="1200" b="0" i="0">
+                <a:solidFill>
+                  <a:srgbClr val="BBDEFB"/>
+                </a:solidFill>
+                <a:latin typeface="Calibri"/>
+              </a:rPr>
+              <a:t>Mulher negra — acesso (CBO 1-4)</a:t>
+            </a:r>
+          </a:p>
+        </p:txBody>
+      </p:sp>
+      <p:sp>
+        <p:nvSpPr>
+          <p:cNvPr id="8" name="TextBox 7"/>
+          <p:cNvSpPr txBox="1"/>
+          <p:nvPr/>
+        </p:nvSpPr>
+        <p:spPr>
+          <a:xfrm>
+            <a:off x="7699248" y="1755648"/>
+            <a:ext cx="3986784" cy="777240"/>
+          </a:xfrm>
+          <a:prstGeom prst="rect">
+            <a:avLst/>
+          </a:prstGeom>
+          <a:noFill/>
+        </p:spPr>
+        <p:txBody>
+          <a:bodyPr wrap="square">
+            <a:spAutoFit/>
+          </a:bodyPr>
+          <a:lstStyle/>
+          <a:p>
+            <a:pPr algn="ctr"/>
+            <a:r>
+              <a:rPr sz="3600" b="1" i="0">
+                <a:solidFill>
+                  <a:srgbClr val="1565C0"/>
+                </a:solidFill>
+                <a:latin typeface="Calibri"/>
+              </a:rPr>
+              <a:t>OR 1,33</a:t>
+            </a:r>
+          </a:p>
+        </p:txBody>
+      </p:sp>
+      <p:sp>
+        <p:nvSpPr>
+          <p:cNvPr id="9" name="TextBox 8"/>
+          <p:cNvSpPr txBox="1"/>
+          <p:nvPr/>
+        </p:nvSpPr>
+        <p:spPr>
+          <a:xfrm>
+            <a:off x="7699248" y="2560320"/>
+            <a:ext cx="3986784" cy="347472"/>
+          </a:xfrm>
+          <a:prstGeom prst="rect">
+            <a:avLst/>
+          </a:prstGeom>
+          <a:noFill/>
+        </p:spPr>
+        <p:txBody>
+          <a:bodyPr wrap="square">
+            <a:spAutoFit/>
+          </a:bodyPr>
+          <a:lstStyle/>
+          <a:p>
+            <a:pPr algn="l"/>
+            <a:r>
+              <a:rPr sz="1000" b="0" i="1">
+                <a:solidFill>
+                  <a:srgbClr val="616161"/>
+                </a:solidFill>
+                <a:latin typeface="Calibri"/>
+              </a:rPr>
+              <a:t>acima do homem branco (profissoes feminizadas)</a:t>
+            </a:r>
+          </a:p>
+        </p:txBody>
+      </p:sp>
+      <p:sp>
+        <p:nvSpPr>
+          <p:cNvPr id="10" name="Rectangle 9"/>
+          <p:cNvSpPr/>
+          <p:nvPr/>
+        </p:nvSpPr>
+        <p:spPr>
+          <a:xfrm>
+            <a:off x="7589520" y="3291840"/>
+            <a:ext cx="4206240" cy="1645920"/>
+          </a:xfrm>
+          <a:prstGeom prst="rect">
+            <a:avLst/>
+          </a:prstGeom>
+          <a:solidFill>
+            <a:srgbClr val="0D1F3C"/>
+          </a:solidFill>
+          <a:ln w="19050">
+            <a:solidFill>
+              <a:srgbClr val="FF8F00"/>
+            </a:solidFill>
+          </a:ln>
+        </p:spPr>
+        <p:style>
+          <a:lnRef idx="1">
+            <a:schemeClr val="accent1"/>
+          </a:lnRef>
+          <a:fillRef idx="3">
+            <a:schemeClr val="accent1"/>
+          </a:fillRef>
+          <a:effectRef idx="2">
+            <a:schemeClr val="accent1"/>
+          </a:effectRef>
+          <a:fontRef idx="minor">
+            <a:schemeClr val="lt1"/>
+          </a:fontRef>
+        </p:style>
+        <p:txBody>
+          <a:bodyPr rtlCol="0" anchor="ctr"/>
+          <a:lstStyle/>
+          <a:p>
+            <a:pPr algn="ctr"/>
+          </a:p>
+        </p:txBody>
+      </p:sp>
+      <p:sp>
+        <p:nvSpPr>
+          <p:cNvPr id="11" name="TextBox 10"/>
+          <p:cNvSpPr txBox="1"/>
+          <p:nvPr/>
+        </p:nvSpPr>
+        <p:spPr>
+          <a:xfrm>
+            <a:off x="7699248" y="3364992"/>
+            <a:ext cx="3986784" cy="347472"/>
+          </a:xfrm>
+          <a:prstGeom prst="rect">
+            <a:avLst/>
+          </a:prstGeom>
+          <a:noFill/>
+        </p:spPr>
+        <p:txBody>
+          <a:bodyPr wrap="square">
+            <a:spAutoFit/>
+          </a:bodyPr>
+          <a:lstStyle/>
+          <a:p>
+            <a:pPr algn="l"/>
+            <a:r>
+              <a:rPr sz="1200" b="0" i="0">
+                <a:solidFill>
+                  <a:srgbClr val="BBDEFB"/>
+                </a:solidFill>
+                <a:latin typeface="Calibri"/>
+              </a:rPr>
+              <a:t>Mulher negra — topo 10% renda</a:t>
+            </a:r>
+          </a:p>
+        </p:txBody>
+      </p:sp>
+      <p:sp>
+        <p:nvSpPr>
+          <p:cNvPr id="12" name="TextBox 11"/>
+          <p:cNvSpPr txBox="1"/>
+          <p:nvPr/>
+        </p:nvSpPr>
+        <p:spPr>
+          <a:xfrm>
+            <a:off x="7699248" y="3675888"/>
+            <a:ext cx="3986784" cy="777240"/>
+          </a:xfrm>
+          <a:prstGeom prst="rect">
+            <a:avLst/>
+          </a:prstGeom>
+          <a:noFill/>
+        </p:spPr>
+        <p:txBody>
+          <a:bodyPr wrap="square">
+            <a:spAutoFit/>
+          </a:bodyPr>
+          <a:lstStyle/>
+          <a:p>
+            <a:pPr algn="ctr"/>
+            <a:r>
+              <a:rPr sz="3600" b="1" i="0">
+                <a:solidFill>
+                  <a:srgbClr val="B71C1C"/>
+                </a:solidFill>
+                <a:latin typeface="Calibri"/>
+              </a:rPr>
+              <a:t>OR 0,34</a:t>
+            </a:r>
+          </a:p>
+        </p:txBody>
+      </p:sp>
+      <p:sp>
+        <p:nvSpPr>
+          <p:cNvPr id="13" name="TextBox 12"/>
+          <p:cNvSpPr txBox="1"/>
+          <p:nvPr/>
+        </p:nvSpPr>
+        <p:spPr>
+          <a:xfrm>
+            <a:off x="7699248" y="4480560"/>
+            <a:ext cx="3986784" cy="347472"/>
+          </a:xfrm>
+          <a:prstGeom prst="rect">
+            <a:avLst/>
+          </a:prstGeom>
+          <a:noFill/>
+        </p:spPr>
+        <p:txBody>
+          <a:bodyPr wrap="square">
+            <a:spAutoFit/>
+          </a:bodyPr>
+          <a:lstStyle/>
+          <a:p>
+            <a:pPr algn="l"/>
+            <a:r>
+              <a:rPr sz="1000" b="0" i="1">
+                <a:solidFill>
+                  <a:srgbClr val="616161"/>
+                </a:solidFill>
+                <a:latin typeface="Calibri"/>
+              </a:rPr>
+              <a:t>a MAIS excluida de todos os grupos</a:t>
+            </a:r>
+          </a:p>
+        </p:txBody>
+      </p:sp>
+      <p:sp>
+        <p:nvSpPr>
+          <p:cNvPr id="14" name="Rectangle 13"/>
+          <p:cNvSpPr/>
+          <p:nvPr/>
+        </p:nvSpPr>
+        <p:spPr>
+          <a:xfrm>
+            <a:off x="365760" y="5897880"/>
+            <a:ext cx="11430000" cy="566928"/>
+          </a:xfrm>
+          <a:prstGeom prst="rect">
+            <a:avLst/>
+          </a:prstGeom>
+          <a:solidFill>
+            <a:srgbClr val="E3F2FD"/>
+          </a:solidFill>
+          <a:ln w="10160">
+            <a:solidFill>
+              <a:srgbClr val="1F3864"/>
+            </a:solidFill>
+          </a:ln>
+        </p:spPr>
+        <p:style>
+          <a:lnRef idx="1">
+            <a:schemeClr val="accent1"/>
+          </a:lnRef>
+          <a:fillRef idx="3">
+            <a:schemeClr val="accent1"/>
+          </a:fillRef>
+          <a:effectRef idx="2">
+            <a:schemeClr val="accent1"/>
+          </a:effectRef>
+          <a:fontRef idx="minor">
+            <a:schemeClr val="lt1"/>
+          </a:fontRef>
+        </p:style>
+        <p:txBody>
+          <a:bodyPr rtlCol="0" anchor="ctr"/>
+          <a:lstStyle/>
+          <a:p>
+            <a:pPr algn="ctr"/>
+          </a:p>
+        </p:txBody>
+      </p:sp>
+      <p:sp>
+        <p:nvSpPr>
+          <p:cNvPr id="15" name="TextBox 14"/>
+          <p:cNvSpPr txBox="1"/>
+          <p:nvPr/>
+        </p:nvSpPr>
+        <p:spPr>
+          <a:xfrm>
+            <a:off x="548640" y="5943600"/>
+            <a:ext cx="11064240" cy="475488"/>
+          </a:xfrm>
+          <a:prstGeom prst="rect">
+            <a:avLst/>
+          </a:prstGeom>
+          <a:noFill/>
+        </p:spPr>
+        <p:txBody>
+          <a:bodyPr wrap="square">
+            <a:spAutoFit/>
+          </a:bodyPr>
+          <a:lstStyle/>
+          <a:p>
+            <a:pPr algn="ctr"/>
+            <a:r>
+              <a:rPr sz="1200" b="1" i="0">
+                <a:solidFill>
+                  <a:srgbClr val="1F3864"/>
+                </a:solidFill>
+                <a:latin typeface="Calibri"/>
+              </a:rPr>
+              <a:t>A mulher negra pode ENTRAR em ocupacoes qualificadas, mas e barrada de CHEGAR AO TOPO da remuneracao: o teto de vidro nao e racial nem sexualmente neutro — combina os dois eixos onde mais importa.</a:t>
+            </a:r>
+          </a:p>
+        </p:txBody>
+      </p:sp>
+      <p:sp>
+        <p:nvSpPr>
+          <p:cNvPr id="16" name="Rectangle 15"/>
+          <p:cNvSpPr/>
+          <p:nvPr/>
+        </p:nvSpPr>
+        <p:spPr>
+          <a:xfrm>
+            <a:off x="0" y="6601968"/>
+            <a:ext cx="12188952" cy="256032"/>
+          </a:xfrm>
+          <a:prstGeom prst="rect">
+            <a:avLst/>
+          </a:prstGeom>
+          <a:solidFill>
+            <a:srgbClr val="1F3864"/>
+          </a:solidFill>
+          <a:ln/>
+        </p:spPr>
+        <p:style>
+          <a:lnRef idx="1">
+            <a:schemeClr val="accent1"/>
+          </a:lnRef>
+          <a:fillRef idx="3">
+            <a:schemeClr val="accent1"/>
+          </a:fillRef>
+          <a:effectRef idx="2">
+            <a:schemeClr val="accent1"/>
+          </a:effectRef>
+          <a:fontRef idx="minor">
+            <a:schemeClr val="lt1"/>
+          </a:fontRef>
+        </p:style>
+        <p:txBody>
+          <a:bodyPr rtlCol="0" anchor="ctr"/>
+          <a:lstStyle/>
+          <a:p>
+            <a:pPr algn="ctr"/>
+          </a:p>
+        </p:txBody>
+      </p:sp>
+      <p:sp>
+        <p:nvSpPr>
+          <p:cNvPr id="17" name="TextBox 16"/>
+          <p:cNvSpPr txBox="1"/>
+          <p:nvPr/>
+        </p:nvSpPr>
+        <p:spPr>
+          <a:xfrm>
+            <a:off x="137160" y="6629400"/>
+            <a:ext cx="10515600" cy="228600"/>
+          </a:xfrm>
+          <a:prstGeom prst="rect">
+            <a:avLst/>
+          </a:prstGeom>
+          <a:noFill/>
+        </p:spPr>
+        <p:txBody>
+          <a:bodyPr wrap="square">
+            <a:spAutoFit/>
+          </a:bodyPr>
+          <a:lstStyle/>
+          <a:p>
+            <a:pPr algn="l"/>
+            <a:r>
+              <a:rPr sz="800" b="0" i="0">
+                <a:solidFill>
+                  <a:srgbClr val="BBDEFB"/>
+                </a:solidFill>
+                <a:latin typeface="Calibri"/>
+              </a:rPr>
+              <a:t>Ricardo Calheiros  |  MBA USP/ESALQ  |  Racismo Estrutural e Mercado de Trabalho  |  Versao Executiva</a:t>
+            </a:r>
+          </a:p>
+        </p:txBody>
+      </p:sp>
+      <p:sp>
+        <p:nvSpPr>
+          <p:cNvPr id="18" name="TextBox 17"/>
+          <p:cNvSpPr txBox="1"/>
+          <p:nvPr/>
+        </p:nvSpPr>
+        <p:spPr>
+          <a:xfrm>
+            <a:off x="11612880" y="6629400"/>
+            <a:ext cx="457200" cy="228600"/>
+          </a:xfrm>
+          <a:prstGeom prst="rect">
+            <a:avLst/>
+          </a:prstGeom>
+          <a:noFill/>
+        </p:spPr>
+        <p:txBody>
+          <a:bodyPr wrap="square">
+            <a:spAutoFit/>
+          </a:bodyPr>
+          <a:lstStyle/>
+          <a:p>
+            <a:pPr algn="r"/>
+            <a:r>
+              <a:rPr sz="800" b="0" i="0">
+                <a:solidFill>
+                  <a:srgbClr val="FFFFFF"/>
+                </a:solidFill>
+                <a:latin typeface="Calibri"/>
+              </a:rPr>
+              <a:t>10/11</a:t>
+            </a:r>
+          </a:p>
+        </p:txBody>
+      </p:sp>
+    </p:spTree>
+  </p:cSld>
+  <p:clrMapOvr>
+    <a:masterClrMapping/>
+  </p:clrMapOvr>
+</p:sld>
+</file>
+
+<file path=ppt/slides/slide11.xml><?xml version="1.0" encoding="utf-8"?>
+<p:sld xmlns:a="http://schemas.openxmlformats.org/drawingml/2006/main" xmlns:p="http://schemas.openxmlformats.org/presentationml/2006/main" xmlns:r="http://schemas.openxmlformats.org/officeDocument/2006/relationships">
+  <p:cSld>
+    <p:spTree>
+      <p:nvGrpSpPr>
+        <p:cNvPr id="1" name=""/>
+        <p:cNvGrpSpPr/>
+        <p:nvPr/>
+      </p:nvGrpSpPr>
+      <p:grpSpPr/>
+      <p:sp>
+        <p:nvSpPr>
+          <p:cNvPr id="2" name="Rectangle 1"/>
+          <p:cNvSpPr/>
+          <p:nvPr/>
+        </p:nvSpPr>
+        <p:spPr>
+          <a:xfrm>
+            <a:off x="0" y="0"/>
+            <a:ext cx="12188952" cy="6858000"/>
+          </a:xfrm>
+          <a:prstGeom prst="rect">
+            <a:avLst/>
+          </a:prstGeom>
+          <a:solidFill>
+            <a:srgbClr val="1F3864"/>
+          </a:solidFill>
+          <a:ln/>
+        </p:spPr>
+        <p:style>
+          <a:lnRef idx="1">
+            <a:schemeClr val="accent1"/>
+          </a:lnRef>
+          <a:fillRef idx="3">
+            <a:schemeClr val="accent1"/>
+          </a:fillRef>
+          <a:effectRef idx="2">
+            <a:schemeClr val="accent1"/>
+          </a:effectRef>
+          <a:fontRef idx="minor">
+            <a:schemeClr val="lt1"/>
+          </a:fontRef>
+        </p:style>
+        <p:txBody>
+          <a:bodyPr rtlCol="0" anchor="ctr"/>
+          <a:lstStyle/>
+          <a:p>
+            <a:pPr algn="ctr"/>
+          </a:p>
+        </p:txBody>
+      </p:sp>
+      <p:sp>
+        <p:nvSpPr>
+          <p:cNvPr id="3" name="Rectangle 2"/>
+          <p:cNvSpPr/>
+          <p:nvPr/>
+        </p:nvSpPr>
+        <p:spPr>
+          <a:xfrm>
+            <a:off x="0" y="0"/>
+            <a:ext cx="12188952" cy="685800"/>
+          </a:xfrm>
+          <a:prstGeom prst="rect">
+            <a:avLst/>
+          </a:prstGeom>
+          <a:solidFill>
+            <a:srgbClr val="0D1F3C"/>
+          </a:solidFill>
+          <a:ln/>
+        </p:spPr>
+        <p:style>
+          <a:lnRef idx="1">
+            <a:schemeClr val="accent1"/>
+          </a:lnRef>
+          <a:fillRef idx="3">
+            <a:schemeClr val="accent1"/>
+          </a:fillRef>
+          <a:effectRef idx="2">
+            <a:schemeClr val="accent1"/>
+          </a:effectRef>
+          <a:fontRef idx="minor">
+            <a:schemeClr val="lt1"/>
+          </a:fontRef>
+        </p:style>
+        <p:txBody>
+          <a:bodyPr rtlCol="0" anchor="ctr"/>
+          <a:lstStyle/>
+          <a:p>
+            <a:pPr algn="ctr"/>
+          </a:p>
+        </p:txBody>
+      </p:sp>
+      <p:sp>
+        <p:nvSpPr>
           <p:cNvPr id="4" name="TextBox 3"/>
           <p:cNvSpPr txBox="1"/>
           <p:nvPr/>
@@ -3954,7 +4599,7 @@
                 </a:solidFill>
                 <a:latin typeface="Calibri"/>
               </a:rPr>
-              <a:t>9. Conclusao — O Que Este Trabalho Prova</a:t>
+              <a:t>10. Conclusao — O Que Este Trabalho Prova</a:t>
             </a:r>
           </a:p>
         </p:txBody>
@@ -5185,7 +5830,42 @@
       </p:sp>
       <p:sp>
         <p:nvSpPr>
-          <p:cNvPr id="37" name="Rectangle 36"/>
+          <p:cNvPr id="37" name="TextBox 36"/>
+          <p:cNvSpPr txBox="1"/>
+          <p:nvPr/>
+        </p:nvSpPr>
+        <p:spPr>
+          <a:xfrm>
+            <a:off x="548640" y="5998464"/>
+            <a:ext cx="11155680" cy="384048"/>
+          </a:xfrm>
+          <a:prstGeom prst="rect">
+            <a:avLst/>
+          </a:prstGeom>
+          <a:noFill/>
+        </p:spPr>
+        <p:txBody>
+          <a:bodyPr wrap="square">
+            <a:spAutoFit/>
+          </a:bodyPr>
+          <a:lstStyle/>
+          <a:p>
+            <a:pPr algn="l"/>
+            <a:r>
+              <a:rPr sz="1100" b="0" i="1">
+                <a:solidFill>
+                  <a:srgbClr val="616161"/>
+                </a:solidFill>
+                <a:latin typeface="Calibri"/>
+              </a:rPr>
+              <a:t>Contexto IBGE (2025): a qualidade de vida avancou (POF), mas a desigualdade de renda voltou a subir (Gini domiciliar per capita 0,491) — o avanco agregado nao fecha o gap racial documentado aqui.</a:t>
+            </a:r>
+          </a:p>
+        </p:txBody>
+      </p:sp>
+      <p:sp>
+        <p:nvSpPr>
+          <p:cNvPr id="38" name="Rectangle 37"/>
           <p:cNvSpPr/>
           <p:nvPr/>
         </p:nvSpPr>
@@ -5226,7 +5906,7 @@
       </p:sp>
       <p:sp>
         <p:nvSpPr>
-          <p:cNvPr id="38" name="TextBox 37"/>
+          <p:cNvPr id="39" name="TextBox 38"/>
           <p:cNvSpPr txBox="1"/>
           <p:nvPr/>
         </p:nvSpPr>
@@ -6076,7 +6756,7 @@
                 </a:solidFill>
                 <a:latin typeface="Calibri"/>
               </a:rPr>
-              <a:t>2/10</a:t>
+              <a:t>2/11</a:t>
             </a:r>
           </a:p>
         </p:txBody>
@@ -7222,7 +7902,7 @@
                 </a:solidFill>
                 <a:latin typeface="Calibri"/>
               </a:rPr>
-              <a:t>3/10</a:t>
+              <a:t>3/11</a:t>
             </a:r>
           </a:p>
         </p:txBody>
@@ -8308,7 +8988,7 @@
                 </a:solidFill>
                 <a:latin typeface="Calibri"/>
               </a:rPr>
-              <a:t>4/10</a:t>
+              <a:t>4/11</a:t>
             </a:r>
           </a:p>
         </p:txBody>
@@ -8737,7 +9417,7 @@
                 </a:solidFill>
                 <a:latin typeface="Calibri"/>
               </a:rPr>
-              <a:t>−4,75 p.p.</a:t>
+              <a:t>−4,73 p.p.</a:t>
             </a:r>
           </a:p>
         </p:txBody>
@@ -9388,7 +10068,7 @@
                 </a:solidFill>
                 <a:latin typeface="Calibri"/>
               </a:rPr>
-              <a:t>5/10</a:t>
+              <a:t>5/11</a:t>
             </a:r>
           </a:p>
         </p:txBody>
@@ -10323,7 +11003,7 @@
                 </a:solidFill>
                 <a:latin typeface="Calibri"/>
               </a:rPr>
-              <a:t>6/10</a:t>
+              <a:t>6/11</a:t>
             </a:r>
           </a:p>
         </p:txBody>
@@ -10844,7 +11524,7 @@
                 </a:solidFill>
                 <a:latin typeface="Calibri"/>
               </a:rPr>
-              <a:t>7/10</a:t>
+              <a:t>7/11</a:t>
             </a:r>
           </a:p>
         </p:txBody>
@@ -11997,7 +12677,7 @@
                 </a:solidFill>
                 <a:latin typeface="Calibri"/>
               </a:rPr>
-              <a:t>8/10</a:t>
+              <a:t>8/11</a:t>
             </a:r>
           </a:p>
         </p:txBody>
@@ -14061,7 +14741,7 @@
                 </a:solidFill>
                 <a:latin typeface="Calibri"/>
               </a:rPr>
-              <a:t>9/10</a:t>
+              <a:t>9/11</a:t>
             </a:r>
           </a:p>
         </p:txBody>

</xml_diff>